<commit_message>
Quote the browser latency as the band it actually is
An independent run of the same harness against the live URL returned a median
of 50.5 ms where the recorded run returned 31.7 ms -- the same 1.6x
irreproducibility this project already documents for GPU throughput on this
host. Stating a single figure a judge can fail to reproduce in the room is the
one thing the rest of the deck refuses to do, so the front page, the README and
the deck now say 30-50 ms and name both recorded runs.

live_demo_check.json is published under verify/ so the second of those two runs
is a file a reader can open, and is listed on the evidence page.

Co-Authored-By: Claude Opus 5 (1M context) <noreply@anthropic.com>
</commit_message>
<xml_diff>
--- a/evidence/deck/JSW_Surface_Defect_Detection.pptx
+++ b/evidence/deck/JSW_Surface_Defect_Detection.pptx
@@ -537,12 +537,22 @@
           <a:p/>
           <a:p>
             <a:r>
-              <a:t>Two honest details if asked. It runs on the WASM backend, single-threaded, 31.7 ms median a frame</a:t>
-            </a:r>
-          </a:p>
-          <a:p>
-            <a:r>
-              <a:t>in Chrome on the machine we measured (site/verify/parity_browser.json); your machine will differ, and</a:t>
+              <a:t>Two honest details if asked. It runs on the WASM backend, single-threaded, 30-50 ms a frame in</a:t>
+            </a:r>
+          </a:p>
+          <a:p>
+            <a:r>
+              <a:t>Chrome on the machine we measured (site/verify/parity_browser.json median 31.7 ms, deck/build/</a:t>
+            </a:r>
+          </a:p>
+          <a:p>
+            <a:r>
+              <a:t>live_demo_check.json median 49.1 ms -- the same harness, 1.6x apart between runs); your machine</a:t>
+            </a:r>
+          </a:p>
+          <a:p>
+            <a:r>
+              <a:t>will differ, and</a:t>
             </a:r>
           </a:p>
           <a:p>
@@ -1404,7 +1414,12 @@
           </a:p>
           <a:p>
             <a:r>
-              <a:t>browser figure obeys the same rule -- 31.7 ms is one machine, one thread, one frame.</a:t>
+              <a:t>browser figure obeys the same rule -- 30-50 ms is one machine, one thread, one frame, and the same</a:t>
+            </a:r>
+          </a:p>
+          <a:p>
+            <a:r>
+              <a:t>harness on the same 12 frames returned medians of 31.7 ms and 49.1 ms in two recorded runs.</a:t>
             </a:r>
           </a:p>
         </p:txBody>
@@ -1793,7 +1808,7 @@
           </a:p>
           <a:p>
             <a:r>
-              <a:t>one frame at a time at about 32 ms; slide 2's arithmetic says a real line at full optical</a:t>
+              <a:t>one frame at a time at 30-50 ms; slide 2's arithmetic says a real line at full optical</a:t>
             </a:r>
           </a:p>
           <a:p>
@@ -8793,7 +8808,7 @@
                 </a:solidFill>
                 <a:latin typeface="Arial"/>
               </a:rPr>
-              <a:t> -- real Chrome, WASM, one thread, 31.7 ms median per frame, 40 of 40 detections identical to PyTorch within 0.14 px. No strip image leaves the plant, no cloud, no per-inference cost, no cold start. A proof of deployability, not a proposal to inspect coil in a browser tab.</a:t>
+              <a:t> -- real Chrome, WASM, one thread, 30-50 ms per frame, 40 of 40 detections identical to PyTorch within 0.14 px. No strip image leaves the plant, no cloud, no per-inference cost, no cold start. A proof of deployability, not a proposal to inspect coil in a browser tab.</a:t>
             </a:r>
           </a:p>
         </p:txBody>
@@ -9030,7 +9045,7 @@
                 </a:solidFill>
                 <a:latin typeface="Arial"/>
               </a:rPr>
-              <a:t>No absolute latency on this host is reproducible between sessions. Every speed statement here is a band or a ratio -- the browser demo's 31.7 ms median included, which is one machine, one WASM thread, one frame at a time, and is not a line rate.</a:t>
+              <a:t>No absolute latency on this host is reproducible between sessions. Every speed statement here is a band or a ratio, never a line rate -- the browser demo included: two recorded runs of the same 12 frames median 31.7 ms and 49.1 ms.</a:t>
             </a:r>
           </a:p>
           <a:p>

</xml_diff>